<commit_message>
Add team name and intro text to title slide
</commit_message>
<xml_diff>
--- a/presentation.pptx
+++ b/presentation.pptx
@@ -1520,6 +1520,95 @@
           </a:p>
         </p:txBody>
       </p:sp>
+      <p:sp>
+        <p:nvSpPr>
+          <p:cNvPr id="10" name="TeamName"/>
+          <p:cNvSpPr/>
+          <p:nvPr/>
+        </p:nvSpPr>
+        <p:spPr>
+          <a:xfrm>
+            <a:off x="1371600" y="3600000"/>
+            <a:ext cx="6400800" cy="380000"/>
+          </a:xfrm>
+          <a:prstGeom prst="rect">
+            <a:avLst/>
+          </a:prstGeom>
+          <a:solidFill>
+            <a:srgbClr val="071E35"/>
+          </a:solidFill>
+          <a:ln w="19050">
+            <a:solidFill>
+              <a:srgbClr val="00C8FF"/>
+            </a:solidFill>
+          </a:ln>
+        </p:spPr>
+        <p:txBody>
+          <a:bodyPr wrap="square" lIns="91440" rIns="91440" rtlCol="0" anchor="ctr"/>
+          <a:lstStyle/>
+          <a:p>
+            <a:pPr marL="0" indent="0" algn="ctr">
+              <a:buNone/>
+            </a:pPr>
+            <a:r>
+              <a:rPr lang="en-US" sz="1300" b="1" dirty="0">
+                <a:solidFill>
+                  <a:srgbClr val="00C8FF"/>
+                </a:solidFill>
+                <a:latin typeface="Calibri" pitchFamily="34" charset="0"/>
+              </a:rPr>
+              <a:t>Team: </a:t>
+            </a:r>
+            <a:r>
+              <a:rPr lang="en-US" sz="1300" b="1" dirty="0">
+                <a:solidFill>
+                  <a:srgbClr val="FFFFFF"/>
+                </a:solidFill>
+                <a:latin typeface="Calibri" pitchFamily="34" charset="0"/>
+              </a:rPr>
+              <a:t>Abhigyan Singh  |  Waseem Raza</a:t>
+            </a:r>
+          </a:p>
+        </p:txBody>
+      </p:sp>
+      <p:sp>
+        <p:nvSpPr>
+          <p:cNvPr id="11" name="IntroText"/>
+          <p:cNvSpPr/>
+          <p:nvPr/>
+        </p:nvSpPr>
+        <p:spPr>
+          <a:xfrm>
+            <a:off x="1371600" y="4060000"/>
+            <a:ext cx="6400800" cy="380000"/>
+          </a:xfrm>
+          <a:prstGeom prst="rect">
+            <a:avLst/>
+          </a:prstGeom>
+          <a:noFill/>
+          <a:ln>
+            <a:noFill/>
+          </a:ln>
+        </p:spPr>
+        <p:txBody>
+          <a:bodyPr wrap="square" rtlCol="0" anchor="ctr"/>
+          <a:lstStyle/>
+          <a:p>
+            <a:pPr marL="0" indent="0" algn="ctr">
+              <a:buNone/>
+            </a:pPr>
+            <a:r>
+              <a:rPr lang="en-US" sz="1100" dirty="0">
+                <a:solidFill>
+                  <a:srgbClr val="8BAFC4"/>
+                </a:solidFill>
+                <a:latin typeface="Calibri" pitchFamily="34" charset="0"/>
+              </a:rPr>
+              <a:t>Helping Indian MSEs find the right BIS standard instantly — using RAG, BM25 + FAISS hybrid retrieval.</a:t>
+            </a:r>
+          </a:p>
+        </p:txBody>
+      </p:sp>
     </p:spTree>
   </p:cSld>
   <p:clrMapOvr>
@@ -7103,7 +7192,7 @@
                 <a:ea typeface="Calibri" pitchFamily="34" charset="-122"/>
                 <a:cs typeface="Calibri" pitchFamily="34" charset="-120"/>
               </a:rPr>
-              <a:t>85%</a:t>
+              <a:t>100%</a:t>
             </a:r>
             <a:endParaRPr lang="en-US" sz="4400" dirty="0"/>
           </a:p>
@@ -7284,7 +7373,7 @@
                 <a:ea typeface="Calibri" pitchFamily="34" charset="-122"/>
                 <a:cs typeface="Calibri" pitchFamily="34" charset="-120"/>
               </a:rPr>
-              <a:t>0.74</a:t>
+              <a:t>0.85</a:t>
             </a:r>
             <a:endParaRPr lang="en-US" sz="4400" dirty="0"/>
           </a:p>
@@ -7465,7 +7554,7 @@
                 <a:ea typeface="Calibri" pitchFamily="34" charset="-122"/>
                 <a:cs typeface="Calibri" pitchFamily="34" charset="-120"/>
               </a:rPr>
-              <a:t>2.1s</a:t>
+              <a:t>0.08s</a:t>
             </a:r>
             <a:endParaRPr lang="en-US" sz="4400" dirty="0"/>
           </a:p>

</xml_diff>

<commit_message>
Update architecture slide 4 and presentation PDF with corrected RAG pipeline
</commit_message>
<xml_diff>
--- a/presentation.pptx
+++ b/presentation.pptx
@@ -11,7 +11,7 @@
     <p:sldId id="256" r:id="rId2"/>
     <p:sldId id="257" r:id="rId3"/>
     <p:sldId id="258" r:id="rId4"/>
-    <p:sldId id="259" r:id="rId5"/>
+    <p:sldId id="264" r:id="rId5"/>
     <p:sldId id="260" r:id="rId6"/>
     <p:sldId id="261" r:id="rId7"/>
     <p:sldId id="262" r:id="rId8"/>
@@ -117,6 +117,65 @@
     </p:ext>
   </p:extLst>
 </p:presentation>
+</file>
+
+<file path=ppt/revisionInfo.xml><?xml version="1.0" encoding="utf-8"?>
+<p1510:revInfo xmlns:a="http://schemas.openxmlformats.org/drawingml/2006/main" xmlns:r="http://schemas.openxmlformats.org/officeDocument/2006/relationships" xmlns:p1510="http://schemas.microsoft.com/office/powerpoint/2015/10/main">
+  <p1510:revLst>
+    <p1510:client id="{E3923A11-7B68-4749-8DC1-4C637BF62A08}" v="2" dt="2026-05-03T07:48:18.816"/>
+  </p1510:revLst>
+</p1510:revInfo>
+</file>
+
+<file path=ppt/changesInfos/changesInfo1.xml><?xml version="1.0" encoding="utf-8"?>
+<pc:chgInfo xmlns:a="http://schemas.openxmlformats.org/drawingml/2006/main" xmlns:r="http://schemas.openxmlformats.org/officeDocument/2006/relationships" xmlns:ac="http://schemas.microsoft.com/office/drawing/2013/main/command" xmlns:pc="http://schemas.microsoft.com/office/powerpoint/2013/main/command">
+  <pc:docChgLst>
+    <pc:chgData name="Abhigyan SINGH" userId="8674384064cd6e03" providerId="LiveId" clId="{28EFE337-EC9F-4D3B-8A1D-3AA28BECFF14}"/>
+    <pc:docChg chg="addSld delSld modSld">
+      <pc:chgData name="Abhigyan SINGH" userId="8674384064cd6e03" providerId="LiveId" clId="{28EFE337-EC9F-4D3B-8A1D-3AA28BECFF14}" dt="2026-05-03T07:49:07.974" v="8" actId="47"/>
+      <pc:docMkLst>
+        <pc:docMk/>
+      </pc:docMkLst>
+      <pc:sldChg chg="addSp modSp del mod">
+        <pc:chgData name="Abhigyan SINGH" userId="8674384064cd6e03" providerId="LiveId" clId="{28EFE337-EC9F-4D3B-8A1D-3AA28BECFF14}" dt="2026-05-03T07:49:07.974" v="8" actId="47"/>
+        <pc:sldMkLst>
+          <pc:docMk/>
+          <pc:sldMk cId="0" sldId="259"/>
+        </pc:sldMkLst>
+        <pc:picChg chg="add mod">
+          <ac:chgData name="Abhigyan SINGH" userId="8674384064cd6e03" providerId="LiveId" clId="{28EFE337-EC9F-4D3B-8A1D-3AA28BECFF14}" dt="2026-05-03T07:48:51.004" v="4" actId="1076"/>
+          <ac:picMkLst>
+            <pc:docMk/>
+            <pc:sldMk cId="0" sldId="259"/>
+            <ac:picMk id="47" creationId="{455529F2-1385-60E9-A2FB-A411A597DE13}"/>
+          </ac:picMkLst>
+        </pc:picChg>
+      </pc:sldChg>
+      <pc:sldChg chg="addSp modSp new mod">
+        <pc:chgData name="Abhigyan SINGH" userId="8674384064cd6e03" providerId="LiveId" clId="{28EFE337-EC9F-4D3B-8A1D-3AA28BECFF14}" dt="2026-05-03T07:49:02.086" v="7" actId="14100"/>
+        <pc:sldMkLst>
+          <pc:docMk/>
+          <pc:sldMk cId="4118586888" sldId="264"/>
+        </pc:sldMkLst>
+        <pc:picChg chg="add mod">
+          <ac:chgData name="Abhigyan SINGH" userId="8674384064cd6e03" providerId="LiveId" clId="{28EFE337-EC9F-4D3B-8A1D-3AA28BECFF14}" dt="2026-05-03T07:49:02.086" v="7" actId="14100"/>
+          <ac:picMkLst>
+            <pc:docMk/>
+            <pc:sldMk cId="4118586888" sldId="264"/>
+            <ac:picMk id="3" creationId="{61A1CA85-4B32-BC1E-755E-6433C03D512C}"/>
+          </ac:picMkLst>
+        </pc:picChg>
+      </pc:sldChg>
+      <pc:sldChg chg="add del setBg">
+        <pc:chgData name="Abhigyan SINGH" userId="8674384064cd6e03" providerId="LiveId" clId="{28EFE337-EC9F-4D3B-8A1D-3AA28BECFF14}" dt="2026-05-03T07:48:18.781" v="2"/>
+        <pc:sldMkLst>
+          <pc:docMk/>
+          <pc:sldMk cId="0" sldId="265"/>
+        </pc:sldMkLst>
+      </pc:sldChg>
+    </pc:docChg>
+  </pc:docChgLst>
+</pc:chgInfo>
 </file>
 
 <file path=ppt/notesMasters/notesMaster1.xml><?xml version="1.0" encoding="utf-8"?>
@@ -561,7 +620,7 @@
           <a:p>
             <a:fld id="{F7021451-1387-4CA6-816F-3879F97B5CBC}" type="slidenum">
               <a:rPr lang="en-US"/>
-              <a:t>4</a:t>
+              <a:t>5</a:t>
             </a:fld>
             <a:endParaRPr lang="en-US"/>
           </a:p>
@@ -645,7 +704,7 @@
           <a:p>
             <a:fld id="{F7021451-1387-4CA6-816F-3879F97B5CBC}" type="slidenum">
               <a:rPr lang="en-US"/>
-              <a:t>5</a:t>
+              <a:t>6</a:t>
             </a:fld>
             <a:endParaRPr lang="en-US"/>
           </a:p>
@@ -729,7 +788,7 @@
           <a:p>
             <a:fld id="{F7021451-1387-4CA6-816F-3879F97B5CBC}" type="slidenum">
               <a:rPr lang="en-US"/>
-              <a:t>6</a:t>
+              <a:t>7</a:t>
             </a:fld>
             <a:endParaRPr lang="en-US"/>
           </a:p>
@@ -749,90 +808,6 @@
 </file>
 
 <file path=ppt/notesSlides/notesSlide7.xml><?xml version="1.0" encoding="utf-8"?>
-<p:notes xmlns:a="http://schemas.openxmlformats.org/drawingml/2006/main" xmlns:r="http://schemas.openxmlformats.org/officeDocument/2006/relationships" xmlns:p="http://schemas.openxmlformats.org/presentationml/2006/main">
-  <p:cSld>
-    <p:spTree>
-      <p:nvGrpSpPr>
-        <p:cNvPr id="1" name=""/>
-        <p:cNvGrpSpPr/>
-        <p:nvPr/>
-      </p:nvGrpSpPr>
-      <p:grpSpPr>
-        <a:xfrm>
-          <a:off x="0" y="0"/>
-          <a:ext cx="0" cy="0"/>
-          <a:chOff x="0" y="0"/>
-          <a:chExt cx="0" cy="0"/>
-        </a:xfrm>
-      </p:grpSpPr>
-      <p:sp>
-        <p:nvSpPr>
-          <p:cNvPr id="2" name="Slide Image Placeholder 1"/>
-          <p:cNvSpPr>
-            <a:spLocks noGrp="1" noRot="1" noChangeAspect="1"/>
-          </p:cNvSpPr>
-          <p:nvPr>
-            <p:ph type="sldImg"/>
-          </p:nvPr>
-        </p:nvSpPr>
-        <p:spPr/>
-      </p:sp>
-      <p:sp>
-        <p:nvSpPr>
-          <p:cNvPr id="3" name="Notes Placeholder 2"/>
-          <p:cNvSpPr>
-            <a:spLocks noGrp="1"/>
-          </p:cNvSpPr>
-          <p:nvPr>
-            <p:ph type="body" idx="1"/>
-          </p:nvPr>
-        </p:nvSpPr>
-        <p:spPr/>
-        <p:txBody>
-          <a:bodyPr/>
-          <a:lstStyle/>
-          <a:p>
-            <a:endParaRPr lang="en-US" dirty="0"/>
-          </a:p>
-        </p:txBody>
-      </p:sp>
-      <p:sp>
-        <p:nvSpPr>
-          <p:cNvPr id="4" name="Slide Number Placeholder 3"/>
-          <p:cNvSpPr>
-            <a:spLocks noGrp="1"/>
-          </p:cNvSpPr>
-          <p:nvPr>
-            <p:ph type="sldNum" sz="quarter" idx="10"/>
-          </p:nvPr>
-        </p:nvSpPr>
-        <p:spPr/>
-        <p:txBody>
-          <a:bodyPr/>
-          <a:lstStyle/>
-          <a:p>
-            <a:fld id="{F7021451-1387-4CA6-816F-3879F97B5CBC}" type="slidenum">
-              <a:rPr lang="en-US"/>
-              <a:t>7</a:t>
-            </a:fld>
-            <a:endParaRPr lang="en-US"/>
-          </a:p>
-        </p:txBody>
-      </p:sp>
-    </p:spTree>
-    <p:extLst>
-      <p:ext uri="{BB962C8B-B14F-4D97-AF65-F5344CB8AC3E}">
-        <p14:creationId xmlns:p14="http://schemas.microsoft.com/office/powerpoint/2010/main" val="1024086991"/>
-      </p:ext>
-    </p:extLst>
-  </p:cSld>
-  <p:clrMapOvr>
-    <a:masterClrMapping/>
-  </p:clrMapOvr>
-</p:notes>
-</file>
-
-<file path=ppt/notesSlides/notesSlide8.xml><?xml version="1.0" encoding="utf-8"?>
 <p:notes xmlns:a="http://schemas.openxmlformats.org/drawingml/2006/main" xmlns:r="http://schemas.openxmlformats.org/officeDocument/2006/relationships" xmlns:p="http://schemas.openxmlformats.org/presentationml/2006/main">
   <p:cSld>
     <p:spTree>
@@ -3504,15 +3479,7 @@
 
 <file path=ppt/slides/slide4.xml><?xml version="1.0" encoding="utf-8"?>
 <p:sld xmlns:a="http://schemas.openxmlformats.org/drawingml/2006/main" xmlns:r="http://schemas.openxmlformats.org/officeDocument/2006/relationships" xmlns:p="http://schemas.openxmlformats.org/presentationml/2006/main">
-  <p:cSld name="Slide 4">
-    <p:bg>
-      <p:bgPr>
-        <a:solidFill>
-          <a:srgbClr val="0A1628"/>
-        </a:solidFill>
-        <a:effectLst/>
-      </p:bgPr>
-    </p:bg>
+  <p:cSld>
     <p:spTree>
       <p:nvGrpSpPr>
         <p:cNvPr id="1" name=""/>
@@ -3527,1561 +3494,42 @@
           <a:chExt cx="0" cy="0"/>
         </a:xfrm>
       </p:grpSpPr>
-      <p:sp>
-        <p:nvSpPr>
-          <p:cNvPr id="2" name="Shape 0"/>
-          <p:cNvSpPr/>
-          <p:nvPr/>
-        </p:nvSpPr>
-        <p:spPr>
-          <a:xfrm>
-            <a:off x="0" y="0"/>
-            <a:ext cx="9144000" cy="64008"/>
-          </a:xfrm>
-          <a:prstGeom prst="rect">
-            <a:avLst/>
-          </a:prstGeom>
-          <a:solidFill>
-            <a:srgbClr val="00C8FF"/>
-          </a:solidFill>
-          <a:ln w="12700">
-            <a:solidFill>
-              <a:srgbClr val="00C8FF"/>
-            </a:solidFill>
-            <a:prstDash val="solid"/>
-          </a:ln>
-        </p:spPr>
-      </p:sp>
-      <p:sp>
-        <p:nvSpPr>
-          <p:cNvPr id="3" name="Shape 1"/>
-          <p:cNvSpPr/>
-          <p:nvPr/>
-        </p:nvSpPr>
-        <p:spPr>
-          <a:xfrm>
-            <a:off x="0" y="5079492"/>
-            <a:ext cx="9144000" cy="64008"/>
-          </a:xfrm>
-          <a:prstGeom prst="rect">
-            <a:avLst/>
-          </a:prstGeom>
-          <a:solidFill>
-            <a:srgbClr val="00C8FF"/>
-          </a:solidFill>
-          <a:ln w="12700">
-            <a:solidFill>
-              <a:srgbClr val="00C8FF"/>
-            </a:solidFill>
-            <a:prstDash val="solid"/>
-          </a:ln>
-        </p:spPr>
-      </p:sp>
-      <p:sp>
-        <p:nvSpPr>
-          <p:cNvPr id="4" name="Text 2"/>
-          <p:cNvSpPr/>
-          <p:nvPr/>
-        </p:nvSpPr>
-        <p:spPr>
-          <a:xfrm>
-            <a:off x="365760" y="182880"/>
-            <a:ext cx="8229600" cy="274320"/>
-          </a:xfrm>
-          <a:prstGeom prst="rect">
-            <a:avLst/>
-          </a:prstGeom>
-          <a:noFill/>
-          <a:ln/>
-        </p:spPr>
-        <p:txBody>
-          <a:bodyPr wrap="square" rtlCol="0" anchor="ctr"/>
-          <a:lstStyle/>
-          <a:p>
-            <a:pPr marL="0" indent="0">
-              <a:buNone/>
-            </a:pPr>
-            <a:r>
-              <a:rPr lang="en-US" sz="900" b="1" dirty="0">
-                <a:solidFill>
-                  <a:srgbClr val="F5A623"/>
-                </a:solidFill>
-                <a:latin typeface="Calibri" pitchFamily="34" charset="0"/>
-                <a:ea typeface="Calibri" pitchFamily="34" charset="-122"/>
-                <a:cs typeface="Calibri" pitchFamily="34" charset="-120"/>
-              </a:rPr>
-              <a:t>03  SYSTEM ARCHITECTURE</a:t>
-            </a:r>
-            <a:endParaRPr lang="en-US" sz="900" dirty="0"/>
-          </a:p>
-        </p:txBody>
-      </p:sp>
-      <p:sp>
-        <p:nvSpPr>
-          <p:cNvPr id="5" name="Text 3"/>
-          <p:cNvSpPr/>
-          <p:nvPr/>
-        </p:nvSpPr>
-        <p:spPr>
-          <a:xfrm>
-            <a:off x="365760" y="502920"/>
-            <a:ext cx="8412480" cy="594360"/>
-          </a:xfrm>
-          <a:prstGeom prst="rect">
-            <a:avLst/>
-          </a:prstGeom>
-          <a:noFill/>
-          <a:ln/>
-        </p:spPr>
-        <p:txBody>
-          <a:bodyPr wrap="square" rtlCol="0" anchor="ctr"/>
-          <a:lstStyle/>
-          <a:p>
-            <a:pPr marL="0" indent="0">
-              <a:buNone/>
-            </a:pPr>
-            <a:r>
-              <a:rPr lang="en-US" sz="2600" b="1" dirty="0">
-                <a:solidFill>
-                  <a:srgbClr val="FFFFFF"/>
-                </a:solidFill>
-                <a:latin typeface="Calibri" pitchFamily="34" charset="0"/>
-                <a:ea typeface="Calibri" pitchFamily="34" charset="-122"/>
-                <a:cs typeface="Calibri" pitchFamily="34" charset="-120"/>
-              </a:rPr>
-              <a:t>End-to-End RAG Pipeline</a:t>
-            </a:r>
-            <a:endParaRPr lang="en-US" sz="2600" dirty="0"/>
-          </a:p>
-        </p:txBody>
-      </p:sp>
-      <p:sp>
-        <p:nvSpPr>
-          <p:cNvPr id="6" name="Shape 4"/>
-          <p:cNvSpPr/>
-          <p:nvPr/>
-        </p:nvSpPr>
-        <p:spPr>
-          <a:xfrm>
-            <a:off x="109728" y="1234440"/>
-            <a:ext cx="1325880" cy="1417320"/>
-          </a:xfrm>
-          <a:prstGeom prst="rect">
-            <a:avLst/>
-          </a:prstGeom>
-          <a:solidFill>
-            <a:srgbClr val="00C8FF"/>
-          </a:solidFill>
-          <a:ln w="12700">
-            <a:solidFill>
-              <a:srgbClr val="00C8FF"/>
-            </a:solidFill>
-            <a:prstDash val="solid"/>
-          </a:ln>
-        </p:spPr>
-      </p:sp>
-      <p:sp>
-        <p:nvSpPr>
-          <p:cNvPr id="7" name="Text 5"/>
-          <p:cNvSpPr/>
-          <p:nvPr/>
-        </p:nvSpPr>
-        <p:spPr>
-          <a:xfrm>
-            <a:off x="109728" y="1325880"/>
-            <a:ext cx="1325880" cy="411480"/>
-          </a:xfrm>
-          <a:prstGeom prst="rect">
-            <a:avLst/>
-          </a:prstGeom>
-          <a:noFill/>
-          <a:ln/>
-        </p:spPr>
-        <p:txBody>
-          <a:bodyPr wrap="square" rtlCol="0" anchor="ctr"/>
-          <a:lstStyle/>
-          <a:p>
-            <a:pPr marL="0" indent="0" algn="ctr">
-              <a:buNone/>
-            </a:pPr>
-            <a:r>
-              <a:rPr lang="en-US" sz="1000" b="1" dirty="0">
-                <a:solidFill>
-                  <a:srgbClr val="0A1628"/>
-                </a:solidFill>
-                <a:latin typeface="Calibri" pitchFamily="34" charset="0"/>
-                <a:ea typeface="Calibri" pitchFamily="34" charset="-122"/>
-                <a:cs typeface="Calibri" pitchFamily="34" charset="-120"/>
-              </a:rPr>
-              <a:t>User Query</a:t>
-            </a:r>
-            <a:endParaRPr lang="en-US" sz="1000" dirty="0"/>
-          </a:p>
-        </p:txBody>
-      </p:sp>
-      <p:sp>
-        <p:nvSpPr>
-          <p:cNvPr id="8" name="Text 6"/>
-          <p:cNvSpPr/>
-          <p:nvPr/>
-        </p:nvSpPr>
-        <p:spPr>
-          <a:xfrm>
-            <a:off x="109728" y="1828800"/>
-            <a:ext cx="1325880" cy="502920"/>
-          </a:xfrm>
-          <a:prstGeom prst="rect">
-            <a:avLst/>
-          </a:prstGeom>
-          <a:noFill/>
-          <a:ln/>
-        </p:spPr>
-        <p:txBody>
-          <a:bodyPr wrap="square" rtlCol="0" anchor="ctr"/>
-          <a:lstStyle/>
-          <a:p>
-            <a:pPr marL="0" indent="0" algn="ctr">
-              <a:buNone/>
-            </a:pPr>
-            <a:r>
-              <a:rPr lang="en-US" sz="900" dirty="0">
-                <a:solidFill>
-                  <a:srgbClr val="0A1628"/>
-                </a:solidFill>
-                <a:latin typeface="Calibri" pitchFamily="34" charset="0"/>
-                <a:ea typeface="Calibri" pitchFamily="34" charset="-122"/>
-                <a:cs typeface="Calibri" pitchFamily="34" charset="-120"/>
-              </a:rPr>
-              <a:t>Natural language</a:t>
-            </a:r>
-            <a:endParaRPr lang="en-US" sz="900" dirty="0"/>
-          </a:p>
-          <a:p>
-            <a:pPr marL="0" indent="0" algn="ctr">
-              <a:buNone/>
-            </a:pPr>
-            <a:r>
-              <a:rPr lang="en-US" sz="900" dirty="0">
-                <a:solidFill>
-                  <a:srgbClr val="0A1628"/>
-                </a:solidFill>
-                <a:latin typeface="Calibri" pitchFamily="34" charset="0"/>
-                <a:ea typeface="Calibri" pitchFamily="34" charset="-122"/>
-                <a:cs typeface="Calibri" pitchFamily="34" charset="-120"/>
-              </a:rPr>
-              <a:t>product description</a:t>
-            </a:r>
-            <a:endParaRPr lang="en-US" sz="900" dirty="0"/>
-          </a:p>
-        </p:txBody>
-      </p:sp>
-      <p:sp>
-        <p:nvSpPr>
-          <p:cNvPr id="9" name="Shape 7"/>
-          <p:cNvSpPr/>
-          <p:nvPr/>
-        </p:nvSpPr>
-        <p:spPr>
-          <a:xfrm>
-            <a:off x="1435608" y="1828800"/>
-            <a:ext cx="164592" cy="73152"/>
-          </a:xfrm>
-          <a:prstGeom prst="rect">
-            <a:avLst/>
-          </a:prstGeom>
-          <a:solidFill>
-            <a:srgbClr val="F5A623"/>
-          </a:solidFill>
-          <a:ln w="12700">
-            <a:solidFill>
-              <a:srgbClr val="F5A623"/>
-            </a:solidFill>
-            <a:prstDash val="solid"/>
-          </a:ln>
-        </p:spPr>
-      </p:sp>
-      <p:sp>
-        <p:nvSpPr>
-          <p:cNvPr id="10" name="Shape 8"/>
-          <p:cNvSpPr/>
-          <p:nvPr/>
-        </p:nvSpPr>
-        <p:spPr>
-          <a:xfrm>
-            <a:off x="1600200" y="1234440"/>
-            <a:ext cx="1325880" cy="1417320"/>
-          </a:xfrm>
-          <a:prstGeom prst="rect">
-            <a:avLst/>
-          </a:prstGeom>
-          <a:solidFill>
-            <a:srgbClr val="1DB8C9"/>
-          </a:solidFill>
-          <a:ln w="12700">
-            <a:solidFill>
-              <a:srgbClr val="1DB8C9"/>
-            </a:solidFill>
-            <a:prstDash val="solid"/>
-          </a:ln>
-        </p:spPr>
-      </p:sp>
-      <p:sp>
-        <p:nvSpPr>
-          <p:cNvPr id="11" name="Text 9"/>
-          <p:cNvSpPr/>
-          <p:nvPr/>
-        </p:nvSpPr>
-        <p:spPr>
-          <a:xfrm>
-            <a:off x="1600200" y="1325880"/>
-            <a:ext cx="1325880" cy="411480"/>
-          </a:xfrm>
-          <a:prstGeom prst="rect">
-            <a:avLst/>
-          </a:prstGeom>
-          <a:noFill/>
-          <a:ln/>
-        </p:spPr>
-        <p:txBody>
-          <a:bodyPr wrap="square" rtlCol="0" anchor="ctr"/>
-          <a:lstStyle/>
-          <a:p>
-            <a:pPr marL="0" indent="0" algn="ctr">
-              <a:buNone/>
-            </a:pPr>
-            <a:r>
-              <a:rPr lang="en-US" sz="1000" b="1" dirty="0">
-                <a:solidFill>
-                  <a:srgbClr val="FFFFFF"/>
-                </a:solidFill>
-                <a:latin typeface="Calibri" pitchFamily="34" charset="0"/>
-                <a:ea typeface="Calibri" pitchFamily="34" charset="-122"/>
-                <a:cs typeface="Calibri" pitchFamily="34" charset="-120"/>
-              </a:rPr>
-              <a:t>Sentence Transformer</a:t>
-            </a:r>
-            <a:endParaRPr lang="en-US" sz="1000" dirty="0"/>
-          </a:p>
-        </p:txBody>
-      </p:sp>
-      <p:sp>
-        <p:nvSpPr>
-          <p:cNvPr id="12" name="Text 10"/>
-          <p:cNvSpPr/>
-          <p:nvPr/>
-        </p:nvSpPr>
-        <p:spPr>
-          <a:xfrm>
-            <a:off x="1600200" y="1828800"/>
-            <a:ext cx="1325880" cy="502920"/>
-          </a:xfrm>
-          <a:prstGeom prst="rect">
-            <a:avLst/>
-          </a:prstGeom>
-          <a:noFill/>
-          <a:ln/>
-        </p:spPr>
-        <p:txBody>
-          <a:bodyPr wrap="square" rtlCol="0" anchor="ctr"/>
-          <a:lstStyle/>
-          <a:p>
-            <a:pPr marL="0" indent="0" algn="ctr">
-              <a:buNone/>
-            </a:pPr>
-            <a:r>
-              <a:rPr lang="en-US" sz="900" dirty="0">
-                <a:solidFill>
-                  <a:srgbClr val="FFFFFF"/>
-                </a:solidFill>
-                <a:latin typeface="Calibri" pitchFamily="34" charset="0"/>
-                <a:ea typeface="Calibri" pitchFamily="34" charset="-122"/>
-                <a:cs typeface="Calibri" pitchFamily="34" charset="-120"/>
-              </a:rPr>
-              <a:t>all-MiniLM-L6-v2</a:t>
-            </a:r>
-            <a:endParaRPr lang="en-US" sz="900" dirty="0"/>
-          </a:p>
-          <a:p>
-            <a:pPr marL="0" indent="0" algn="ctr">
-              <a:buNone/>
-            </a:pPr>
-            <a:r>
-              <a:rPr lang="en-US" sz="900" dirty="0">
-                <a:solidFill>
-                  <a:srgbClr val="FFFFFF"/>
-                </a:solidFill>
-                <a:latin typeface="Calibri" pitchFamily="34" charset="0"/>
-                <a:ea typeface="Calibri" pitchFamily="34" charset="-122"/>
-                <a:cs typeface="Calibri" pitchFamily="34" charset="-120"/>
-              </a:rPr>
-              <a:t>Embedding</a:t>
-            </a:r>
-            <a:endParaRPr lang="en-US" sz="900" dirty="0"/>
-          </a:p>
-        </p:txBody>
-      </p:sp>
-      <p:sp>
-        <p:nvSpPr>
-          <p:cNvPr id="13" name="Shape 11"/>
-          <p:cNvSpPr/>
-          <p:nvPr/>
-        </p:nvSpPr>
-        <p:spPr>
-          <a:xfrm>
-            <a:off x="2926080" y="1828800"/>
-            <a:ext cx="164592" cy="73152"/>
-          </a:xfrm>
-          <a:prstGeom prst="rect">
-            <a:avLst/>
-          </a:prstGeom>
-          <a:solidFill>
-            <a:srgbClr val="F5A623"/>
-          </a:solidFill>
-          <a:ln w="12700">
-            <a:solidFill>
-              <a:srgbClr val="F5A623"/>
-            </a:solidFill>
-            <a:prstDash val="solid"/>
-          </a:ln>
-        </p:spPr>
-      </p:sp>
-      <p:sp>
-        <p:nvSpPr>
-          <p:cNvPr id="14" name="Shape 12"/>
-          <p:cNvSpPr/>
-          <p:nvPr/>
-        </p:nvSpPr>
-        <p:spPr>
-          <a:xfrm>
-            <a:off x="3090672" y="1234440"/>
-            <a:ext cx="1325880" cy="1417320"/>
-          </a:xfrm>
-          <a:prstGeom prst="rect">
-            <a:avLst/>
-          </a:prstGeom>
-          <a:solidFill>
-            <a:srgbClr val="1DB8C9"/>
-          </a:solidFill>
-          <a:ln w="12700">
-            <a:solidFill>
-              <a:srgbClr val="1DB8C9"/>
-            </a:solidFill>
-            <a:prstDash val="solid"/>
-          </a:ln>
-        </p:spPr>
-      </p:sp>
-      <p:sp>
-        <p:nvSpPr>
-          <p:cNvPr id="15" name="Text 13"/>
-          <p:cNvSpPr/>
-          <p:nvPr/>
-        </p:nvSpPr>
-        <p:spPr>
-          <a:xfrm>
-            <a:off x="3090672" y="1325880"/>
-            <a:ext cx="1325880" cy="411480"/>
-          </a:xfrm>
-          <a:prstGeom prst="rect">
-            <a:avLst/>
-          </a:prstGeom>
-          <a:noFill/>
-          <a:ln/>
-        </p:spPr>
-        <p:txBody>
-          <a:bodyPr wrap="square" rtlCol="0" anchor="ctr"/>
-          <a:lstStyle/>
-          <a:p>
-            <a:pPr marL="0" indent="0" algn="ctr">
-              <a:buNone/>
-            </a:pPr>
-            <a:r>
-              <a:rPr lang="en-US" sz="1000" b="1" dirty="0">
-                <a:solidFill>
-                  <a:srgbClr val="FFFFFF"/>
-                </a:solidFill>
-                <a:latin typeface="Calibri" pitchFamily="34" charset="0"/>
-                <a:ea typeface="Calibri" pitchFamily="34" charset="-122"/>
-                <a:cs typeface="Calibri" pitchFamily="34" charset="-120"/>
-              </a:rPr>
-              <a:t>FAISS Index Search</a:t>
-            </a:r>
-            <a:endParaRPr lang="en-US" sz="1000" dirty="0"/>
-          </a:p>
-        </p:txBody>
-      </p:sp>
-      <p:sp>
-        <p:nvSpPr>
-          <p:cNvPr id="16" name="Text 14"/>
-          <p:cNvSpPr/>
-          <p:nvPr/>
-        </p:nvSpPr>
-        <p:spPr>
-          <a:xfrm>
-            <a:off x="3090672" y="1828800"/>
-            <a:ext cx="1325880" cy="502920"/>
-          </a:xfrm>
-          <a:prstGeom prst="rect">
-            <a:avLst/>
-          </a:prstGeom>
-          <a:noFill/>
-          <a:ln/>
-        </p:spPr>
-        <p:txBody>
-          <a:bodyPr wrap="square" rtlCol="0" anchor="ctr"/>
-          <a:lstStyle/>
-          <a:p>
-            <a:pPr marL="0" indent="0" algn="ctr">
-              <a:buNone/>
-            </a:pPr>
-            <a:r>
-              <a:rPr lang="en-US" sz="900" dirty="0">
-                <a:solidFill>
-                  <a:srgbClr val="FFFFFF"/>
-                </a:solidFill>
-                <a:latin typeface="Calibri" pitchFamily="34" charset="0"/>
-                <a:ea typeface="Calibri" pitchFamily="34" charset="-122"/>
-                <a:cs typeface="Calibri" pitchFamily="34" charset="-120"/>
-              </a:rPr>
-              <a:t>Cosine similarity</a:t>
-            </a:r>
-            <a:endParaRPr lang="en-US" sz="900" dirty="0"/>
-          </a:p>
-          <a:p>
-            <a:pPr marL="0" indent="0" algn="ctr">
-              <a:buNone/>
-            </a:pPr>
-            <a:r>
-              <a:rPr lang="en-US" sz="900" dirty="0">
-                <a:solidFill>
-                  <a:srgbClr val="FFFFFF"/>
-                </a:solidFill>
-                <a:latin typeface="Calibri" pitchFamily="34" charset="0"/>
-                <a:ea typeface="Calibri" pitchFamily="34" charset="-122"/>
-                <a:cs typeface="Calibri" pitchFamily="34" charset="-120"/>
-              </a:rPr>
-              <a:t>Top-K=10 results</a:t>
-            </a:r>
-            <a:endParaRPr lang="en-US" sz="900" dirty="0"/>
-          </a:p>
-        </p:txBody>
-      </p:sp>
-      <p:sp>
-        <p:nvSpPr>
-          <p:cNvPr id="17" name="Shape 15"/>
-          <p:cNvSpPr/>
-          <p:nvPr/>
-        </p:nvSpPr>
-        <p:spPr>
-          <a:xfrm>
-            <a:off x="4416552" y="1828800"/>
-            <a:ext cx="164592" cy="73152"/>
-          </a:xfrm>
-          <a:prstGeom prst="rect">
-            <a:avLst/>
-          </a:prstGeom>
-          <a:solidFill>
-            <a:srgbClr val="F5A623"/>
-          </a:solidFill>
-          <a:ln w="12700">
-            <a:solidFill>
-              <a:srgbClr val="F5A623"/>
-            </a:solidFill>
-            <a:prstDash val="solid"/>
-          </a:ln>
-        </p:spPr>
-      </p:sp>
-      <p:sp>
-        <p:nvSpPr>
-          <p:cNvPr id="18" name="Shape 16"/>
-          <p:cNvSpPr/>
-          <p:nvPr/>
-        </p:nvSpPr>
-        <p:spPr>
-          <a:xfrm>
-            <a:off x="4581144" y="1234440"/>
-            <a:ext cx="1325880" cy="1417320"/>
-          </a:xfrm>
-          <a:prstGeom prst="rect">
-            <a:avLst/>
-          </a:prstGeom>
-          <a:solidFill>
-            <a:srgbClr val="1DB8C9"/>
-          </a:solidFill>
-          <a:ln w="12700">
-            <a:solidFill>
-              <a:srgbClr val="1DB8C9"/>
-            </a:solidFill>
-            <a:prstDash val="solid"/>
-          </a:ln>
-        </p:spPr>
-      </p:sp>
-      <p:sp>
-        <p:nvSpPr>
-          <p:cNvPr id="19" name="Text 17"/>
-          <p:cNvSpPr/>
-          <p:nvPr/>
-        </p:nvSpPr>
-        <p:spPr>
-          <a:xfrm>
-            <a:off x="4581144" y="1325880"/>
-            <a:ext cx="1325880" cy="411480"/>
-          </a:xfrm>
-          <a:prstGeom prst="rect">
-            <a:avLst/>
-          </a:prstGeom>
-          <a:noFill/>
-          <a:ln/>
-        </p:spPr>
-        <p:txBody>
-          <a:bodyPr wrap="square" rtlCol="0" anchor="ctr"/>
-          <a:lstStyle/>
-          <a:p>
-            <a:pPr marL="0" indent="0" algn="ctr">
-              <a:buNone/>
-            </a:pPr>
-            <a:r>
-              <a:rPr lang="en-US" sz="1000" b="1" dirty="0">
-                <a:solidFill>
-                  <a:srgbClr val="FFFFFF"/>
-                </a:solidFill>
-                <a:latin typeface="Calibri" pitchFamily="34" charset="0"/>
-                <a:ea typeface="Calibri" pitchFamily="34" charset="-122"/>
-                <a:cs typeface="Calibri" pitchFamily="34" charset="-120"/>
-              </a:rPr>
-              <a:t>Keyword Reranker</a:t>
-            </a:r>
-            <a:endParaRPr lang="en-US" sz="1000" dirty="0"/>
-          </a:p>
-        </p:txBody>
-      </p:sp>
-      <p:sp>
-        <p:nvSpPr>
-          <p:cNvPr id="20" name="Text 18"/>
-          <p:cNvSpPr/>
-          <p:nvPr/>
-        </p:nvSpPr>
-        <p:spPr>
-          <a:xfrm>
-            <a:off x="4581144" y="1828800"/>
-            <a:ext cx="1325880" cy="502920"/>
-          </a:xfrm>
-          <a:prstGeom prst="rect">
-            <a:avLst/>
-          </a:prstGeom>
-          <a:noFill/>
-          <a:ln/>
-        </p:spPr>
-        <p:txBody>
-          <a:bodyPr wrap="square" rtlCol="0" anchor="ctr"/>
-          <a:lstStyle/>
-          <a:p>
-            <a:pPr marL="0" indent="0" algn="ctr">
-              <a:buNone/>
-            </a:pPr>
-            <a:r>
-              <a:rPr lang="en-US" sz="900" dirty="0">
-                <a:solidFill>
-                  <a:srgbClr val="FFFFFF"/>
-                </a:solidFill>
-                <a:latin typeface="Calibri" pitchFamily="34" charset="0"/>
-                <a:ea typeface="Calibri" pitchFamily="34" charset="-122"/>
-                <a:cs typeface="Calibri" pitchFamily="34" charset="-120"/>
-              </a:rPr>
-              <a:t>Hybrid scoring</a:t>
-            </a:r>
-            <a:endParaRPr lang="en-US" sz="900" dirty="0"/>
-          </a:p>
-          <a:p>
-            <a:pPr marL="0" indent="0" algn="ctr">
-              <a:buNone/>
-            </a:pPr>
-            <a:r>
-              <a:rPr lang="en-US" sz="900" dirty="0">
-                <a:solidFill>
-                  <a:srgbClr val="FFFFFF"/>
-                </a:solidFill>
-                <a:latin typeface="Calibri" pitchFamily="34" charset="0"/>
-                <a:ea typeface="Calibri" pitchFamily="34" charset="-122"/>
-                <a:cs typeface="Calibri" pitchFamily="34" charset="-120"/>
-              </a:rPr>
-              <a:t>Top-5 shortlist</a:t>
-            </a:r>
-            <a:endParaRPr lang="en-US" sz="900" dirty="0"/>
-          </a:p>
-        </p:txBody>
-      </p:sp>
-      <p:sp>
-        <p:nvSpPr>
-          <p:cNvPr id="21" name="Shape 19"/>
-          <p:cNvSpPr/>
-          <p:nvPr/>
-        </p:nvSpPr>
-        <p:spPr>
-          <a:xfrm>
-            <a:off x="5907024" y="1828800"/>
-            <a:ext cx="164592" cy="73152"/>
-          </a:xfrm>
-          <a:prstGeom prst="rect">
-            <a:avLst/>
-          </a:prstGeom>
-          <a:solidFill>
-            <a:srgbClr val="F5A623"/>
-          </a:solidFill>
-          <a:ln w="12700">
-            <a:solidFill>
-              <a:srgbClr val="F5A623"/>
-            </a:solidFill>
-            <a:prstDash val="solid"/>
-          </a:ln>
-        </p:spPr>
-      </p:sp>
-      <p:sp>
-        <p:nvSpPr>
-          <p:cNvPr id="22" name="Shape 20"/>
-          <p:cNvSpPr/>
-          <p:nvPr/>
-        </p:nvSpPr>
-        <p:spPr>
-          <a:xfrm>
-            <a:off x="6071616" y="1234440"/>
-            <a:ext cx="1325880" cy="1417320"/>
-          </a:xfrm>
-          <a:prstGeom prst="rect">
-            <a:avLst/>
-          </a:prstGeom>
-          <a:solidFill>
-            <a:srgbClr val="1DB8C9"/>
-          </a:solidFill>
-          <a:ln w="12700">
-            <a:solidFill>
-              <a:srgbClr val="1DB8C9"/>
-            </a:solidFill>
-            <a:prstDash val="solid"/>
-          </a:ln>
-        </p:spPr>
-      </p:sp>
-      <p:sp>
-        <p:nvSpPr>
-          <p:cNvPr id="23" name="Text 21"/>
-          <p:cNvSpPr/>
-          <p:nvPr/>
-        </p:nvSpPr>
-        <p:spPr>
-          <a:xfrm>
-            <a:off x="6071616" y="1325880"/>
-            <a:ext cx="1325880" cy="411480"/>
-          </a:xfrm>
-          <a:prstGeom prst="rect">
-            <a:avLst/>
-          </a:prstGeom>
-          <a:noFill/>
-          <a:ln/>
-        </p:spPr>
-        <p:txBody>
-          <a:bodyPr wrap="square" rtlCol="0" anchor="ctr"/>
-          <a:lstStyle/>
-          <a:p>
-            <a:pPr marL="0" indent="0" algn="ctr">
-              <a:buNone/>
-            </a:pPr>
-            <a:r>
-              <a:rPr lang="en-US" sz="1000" b="1" dirty="0">
-                <a:solidFill>
-                  <a:srgbClr val="FFFFFF"/>
-                </a:solidFill>
-                <a:latin typeface="Calibri" pitchFamily="34" charset="0"/>
-                <a:ea typeface="Calibri" pitchFamily="34" charset="-122"/>
-                <a:cs typeface="Calibri" pitchFamily="34" charset="-120"/>
-              </a:rPr>
-              <a:t>Groq LLM</a:t>
-            </a:r>
-            <a:endParaRPr lang="en-US" sz="1000" dirty="0"/>
-          </a:p>
-        </p:txBody>
-      </p:sp>
-      <p:sp>
-        <p:nvSpPr>
-          <p:cNvPr id="24" name="Text 22"/>
-          <p:cNvSpPr/>
-          <p:nvPr/>
-        </p:nvSpPr>
-        <p:spPr>
-          <a:xfrm>
-            <a:off x="6071616" y="1828800"/>
-            <a:ext cx="1325880" cy="502920"/>
-          </a:xfrm>
-          <a:prstGeom prst="rect">
-            <a:avLst/>
-          </a:prstGeom>
-          <a:noFill/>
-          <a:ln/>
-        </p:spPr>
-        <p:txBody>
-          <a:bodyPr wrap="square" rtlCol="0" anchor="ctr"/>
-          <a:lstStyle/>
-          <a:p>
-            <a:pPr marL="0" indent="0" algn="ctr">
-              <a:buNone/>
-            </a:pPr>
-            <a:r>
-              <a:rPr lang="en-US" sz="900" dirty="0">
-                <a:solidFill>
-                  <a:srgbClr val="FFFFFF"/>
-                </a:solidFill>
-                <a:latin typeface="Calibri" pitchFamily="34" charset="0"/>
-                <a:ea typeface="Calibri" pitchFamily="34" charset="-122"/>
-                <a:cs typeface="Calibri" pitchFamily="34" charset="-120"/>
-              </a:rPr>
-              <a:t>Llama 3.1 8B</a:t>
-            </a:r>
-            <a:endParaRPr lang="en-US" sz="900" dirty="0"/>
-          </a:p>
-          <a:p>
-            <a:pPr marL="0" indent="0" algn="ctr">
-              <a:buNone/>
-            </a:pPr>
-            <a:r>
-              <a:rPr lang="en-US" sz="900" dirty="0">
-                <a:solidFill>
-                  <a:srgbClr val="FFFFFF"/>
-                </a:solidFill>
-                <a:latin typeface="Calibri" pitchFamily="34" charset="0"/>
-                <a:ea typeface="Calibri" pitchFamily="34" charset="-122"/>
-                <a:cs typeface="Calibri" pitchFamily="34" charset="-120"/>
-              </a:rPr>
-              <a:t>Rationale gen</a:t>
-            </a:r>
-            <a:endParaRPr lang="en-US" sz="900" dirty="0"/>
-          </a:p>
-        </p:txBody>
-      </p:sp>
-      <p:sp>
-        <p:nvSpPr>
-          <p:cNvPr id="25" name="Shape 23"/>
-          <p:cNvSpPr/>
-          <p:nvPr/>
-        </p:nvSpPr>
-        <p:spPr>
-          <a:xfrm>
-            <a:off x="7397496" y="1828800"/>
-            <a:ext cx="164592" cy="73152"/>
-          </a:xfrm>
-          <a:prstGeom prst="rect">
-            <a:avLst/>
-          </a:prstGeom>
-          <a:solidFill>
-            <a:srgbClr val="F5A623"/>
-          </a:solidFill>
-          <a:ln w="12700">
-            <a:solidFill>
-              <a:srgbClr val="F5A623"/>
-            </a:solidFill>
-            <a:prstDash val="solid"/>
-          </a:ln>
-        </p:spPr>
-      </p:sp>
-      <p:sp>
-        <p:nvSpPr>
-          <p:cNvPr id="26" name="Shape 24"/>
-          <p:cNvSpPr/>
-          <p:nvPr/>
-        </p:nvSpPr>
-        <p:spPr>
-          <a:xfrm>
-            <a:off x="7562088" y="1234440"/>
-            <a:ext cx="1325880" cy="1417320"/>
-          </a:xfrm>
-          <a:prstGeom prst="rect">
-            <a:avLst/>
-          </a:prstGeom>
-          <a:solidFill>
-            <a:srgbClr val="00C8FF"/>
-          </a:solidFill>
-          <a:ln w="12700">
-            <a:solidFill>
-              <a:srgbClr val="00C8FF"/>
-            </a:solidFill>
-            <a:prstDash val="solid"/>
-          </a:ln>
-        </p:spPr>
-      </p:sp>
-      <p:sp>
-        <p:nvSpPr>
-          <p:cNvPr id="27" name="Text 25"/>
-          <p:cNvSpPr/>
-          <p:nvPr/>
-        </p:nvSpPr>
-        <p:spPr>
-          <a:xfrm>
-            <a:off x="7562088" y="1325880"/>
-            <a:ext cx="1325880" cy="411480"/>
-          </a:xfrm>
-          <a:prstGeom prst="rect">
-            <a:avLst/>
-          </a:prstGeom>
-          <a:noFill/>
-          <a:ln/>
-        </p:spPr>
-        <p:txBody>
-          <a:bodyPr wrap="square" rtlCol="0" anchor="ctr"/>
-          <a:lstStyle/>
-          <a:p>
-            <a:pPr marL="0" indent="0" algn="ctr">
-              <a:buNone/>
-            </a:pPr>
-            <a:r>
-              <a:rPr lang="en-US" sz="1000" b="1" dirty="0">
-                <a:solidFill>
-                  <a:srgbClr val="0A1628"/>
-                </a:solidFill>
-                <a:latin typeface="Calibri" pitchFamily="34" charset="0"/>
-                <a:ea typeface="Calibri" pitchFamily="34" charset="-122"/>
-                <a:cs typeface="Calibri" pitchFamily="34" charset="-120"/>
-              </a:rPr>
-              <a:t>JSON Output</a:t>
-            </a:r>
-            <a:endParaRPr lang="en-US" sz="1000" dirty="0"/>
-          </a:p>
-        </p:txBody>
-      </p:sp>
-      <p:sp>
-        <p:nvSpPr>
-          <p:cNvPr id="28" name="Text 26"/>
-          <p:cNvSpPr/>
-          <p:nvPr/>
-        </p:nvSpPr>
-        <p:spPr>
-          <a:xfrm>
-            <a:off x="7562088" y="1828800"/>
-            <a:ext cx="1325880" cy="502920"/>
-          </a:xfrm>
-          <a:prstGeom prst="rect">
-            <a:avLst/>
-          </a:prstGeom>
-          <a:noFill/>
-          <a:ln/>
-        </p:spPr>
-        <p:txBody>
-          <a:bodyPr wrap="square" rtlCol="0" anchor="ctr"/>
-          <a:lstStyle/>
-          <a:p>
-            <a:pPr marL="0" indent="0" algn="ctr">
-              <a:buNone/>
-            </a:pPr>
-            <a:r>
-              <a:rPr lang="en-US" sz="900" dirty="0">
-                <a:solidFill>
-                  <a:srgbClr val="0A1628"/>
-                </a:solidFill>
-                <a:latin typeface="Calibri" pitchFamily="34" charset="0"/>
-                <a:ea typeface="Calibri" pitchFamily="34" charset="-122"/>
-                <a:cs typeface="Calibri" pitchFamily="34" charset="-120"/>
-              </a:rPr>
-              <a:t>standard + reason</a:t>
-            </a:r>
-            <a:endParaRPr lang="en-US" sz="900" dirty="0"/>
-          </a:p>
-          <a:p>
-            <a:pPr marL="0" indent="0" algn="ctr">
-              <a:buNone/>
-            </a:pPr>
-            <a:r>
-              <a:rPr lang="en-US" sz="900" dirty="0">
-                <a:solidFill>
-                  <a:srgbClr val="0A1628"/>
-                </a:solidFill>
-                <a:latin typeface="Calibri" pitchFamily="34" charset="0"/>
-                <a:ea typeface="Calibri" pitchFamily="34" charset="-122"/>
-                <a:cs typeface="Calibri" pitchFamily="34" charset="-120"/>
-              </a:rPr>
-              <a:t>id + latency</a:t>
-            </a:r>
-            <a:endParaRPr lang="en-US" sz="900" dirty="0"/>
-          </a:p>
-        </p:txBody>
-      </p:sp>
-      <p:sp>
-        <p:nvSpPr>
-          <p:cNvPr id="29" name="Text 27"/>
-          <p:cNvSpPr/>
-          <p:nvPr/>
-        </p:nvSpPr>
-        <p:spPr>
-          <a:xfrm>
-            <a:off x="365760" y="2880360"/>
-            <a:ext cx="3657600" cy="274320"/>
-          </a:xfrm>
-          <a:prstGeom prst="rect">
-            <a:avLst/>
-          </a:prstGeom>
-          <a:noFill/>
-          <a:ln/>
-        </p:spPr>
-        <p:txBody>
-          <a:bodyPr wrap="square" rtlCol="0" anchor="ctr"/>
-          <a:lstStyle/>
-          <a:p>
-            <a:pPr marL="0" indent="0">
-              <a:buNone/>
-            </a:pPr>
-            <a:r>
-              <a:rPr lang="en-US" sz="1000" b="1" dirty="0">
-                <a:solidFill>
-                  <a:srgbClr val="F5A623"/>
-                </a:solidFill>
-                <a:latin typeface="Calibri" pitchFamily="34" charset="0"/>
-                <a:ea typeface="Calibri" pitchFamily="34" charset="-122"/>
-                <a:cs typeface="Calibri" pitchFamily="34" charset="-120"/>
-              </a:rPr>
-              <a:t>DATA INGESTION (one-time):</a:t>
-            </a:r>
-            <a:endParaRPr lang="en-US" sz="1000" dirty="0"/>
-          </a:p>
-        </p:txBody>
-      </p:sp>
-      <p:sp>
-        <p:nvSpPr>
-          <p:cNvPr id="30" name="Shape 28"/>
-          <p:cNvSpPr/>
-          <p:nvPr/>
-        </p:nvSpPr>
-        <p:spPr>
-          <a:xfrm>
-            <a:off x="109728" y="3246120"/>
-            <a:ext cx="1600200" cy="502920"/>
-          </a:xfrm>
-          <a:prstGeom prst="rect">
-            <a:avLst/>
-          </a:prstGeom>
-          <a:solidFill>
-            <a:srgbClr val="0D2137"/>
-          </a:solidFill>
-          <a:ln w="12700">
-            <a:solidFill>
-              <a:srgbClr val="1DB8C9"/>
-            </a:solidFill>
-            <a:prstDash val="solid"/>
-          </a:ln>
-        </p:spPr>
-      </p:sp>
-      <p:sp>
-        <p:nvSpPr>
-          <p:cNvPr id="31" name="Text 29"/>
-          <p:cNvSpPr/>
-          <p:nvPr/>
-        </p:nvSpPr>
-        <p:spPr>
-          <a:xfrm>
-            <a:off x="109728" y="3246120"/>
-            <a:ext cx="1600200" cy="502920"/>
-          </a:xfrm>
-          <a:prstGeom prst="rect">
-            <a:avLst/>
-          </a:prstGeom>
-          <a:noFill/>
-          <a:ln/>
-        </p:spPr>
-        <p:txBody>
-          <a:bodyPr wrap="square" rtlCol="0" anchor="ctr"/>
-          <a:lstStyle/>
-          <a:p>
-            <a:pPr marL="0" indent="0" algn="ctr">
-              <a:buNone/>
-            </a:pPr>
-            <a:r>
-              <a:rPr lang="en-US" sz="1000" b="1" dirty="0">
-                <a:solidFill>
-                  <a:srgbClr val="FFFFFF"/>
-                </a:solidFill>
-                <a:latin typeface="Calibri" pitchFamily="34" charset="0"/>
-                <a:ea typeface="Calibri" pitchFamily="34" charset="-122"/>
-                <a:cs typeface="Calibri" pitchFamily="34" charset="-120"/>
-              </a:rPr>
-              <a:t>BIS SP 21 PDF</a:t>
-            </a:r>
-            <a:endParaRPr lang="en-US" sz="1000" dirty="0"/>
-          </a:p>
-        </p:txBody>
-      </p:sp>
-      <p:sp>
-        <p:nvSpPr>
-          <p:cNvPr id="32" name="Text 30"/>
-          <p:cNvSpPr/>
-          <p:nvPr/>
-        </p:nvSpPr>
-        <p:spPr>
-          <a:xfrm>
-            <a:off x="1709928" y="3337560"/>
-            <a:ext cx="182880" cy="320040"/>
-          </a:xfrm>
-          <a:prstGeom prst="rect">
-            <a:avLst/>
-          </a:prstGeom>
-          <a:noFill/>
-          <a:ln/>
-        </p:spPr>
-        <p:txBody>
-          <a:bodyPr wrap="square" rtlCol="0" anchor="ctr"/>
-          <a:lstStyle/>
-          <a:p>
-            <a:pPr marL="0" indent="0" algn="ctr">
-              <a:buNone/>
-            </a:pPr>
-            <a:r>
-              <a:rPr lang="en-US" sz="1200" dirty="0">
-                <a:solidFill>
-                  <a:srgbClr val="8BAFC4"/>
-                </a:solidFill>
-              </a:rPr>
-              <a:t>→</a:t>
-            </a:r>
-            <a:endParaRPr lang="en-US" sz="1200" dirty="0"/>
-          </a:p>
-        </p:txBody>
-      </p:sp>
-      <p:sp>
-        <p:nvSpPr>
-          <p:cNvPr id="33" name="Shape 31"/>
-          <p:cNvSpPr/>
-          <p:nvPr/>
-        </p:nvSpPr>
-        <p:spPr>
-          <a:xfrm>
-            <a:off x="1892808" y="3246120"/>
-            <a:ext cx="1600200" cy="502920"/>
-          </a:xfrm>
-          <a:prstGeom prst="rect">
-            <a:avLst/>
-          </a:prstGeom>
-          <a:solidFill>
-            <a:srgbClr val="0E2A45"/>
-          </a:solidFill>
-          <a:ln w="12700">
-            <a:solidFill>
-              <a:srgbClr val="1DB8C9"/>
-            </a:solidFill>
-            <a:prstDash val="solid"/>
-          </a:ln>
-        </p:spPr>
-      </p:sp>
-      <p:sp>
-        <p:nvSpPr>
-          <p:cNvPr id="34" name="Text 32"/>
-          <p:cNvSpPr/>
-          <p:nvPr/>
-        </p:nvSpPr>
-        <p:spPr>
-          <a:xfrm>
-            <a:off x="1892808" y="3246120"/>
-            <a:ext cx="1600200" cy="502920"/>
-          </a:xfrm>
-          <a:prstGeom prst="rect">
-            <a:avLst/>
-          </a:prstGeom>
-          <a:noFill/>
-          <a:ln/>
-        </p:spPr>
-        <p:txBody>
-          <a:bodyPr wrap="square" rtlCol="0" anchor="ctr"/>
-          <a:lstStyle/>
-          <a:p>
-            <a:pPr marL="0" indent="0" algn="ctr">
-              <a:buNone/>
-            </a:pPr>
-            <a:r>
-              <a:rPr lang="en-US" sz="1000" dirty="0">
-                <a:solidFill>
-                  <a:srgbClr val="FFFFFF"/>
-                </a:solidFill>
-                <a:latin typeface="Calibri" pitchFamily="34" charset="0"/>
-                <a:ea typeface="Calibri" pitchFamily="34" charset="-122"/>
-                <a:cs typeface="Calibri" pitchFamily="34" charset="-120"/>
-              </a:rPr>
-              <a:t>PyMuPDF Parser</a:t>
-            </a:r>
-            <a:endParaRPr lang="en-US" sz="1000" dirty="0"/>
-          </a:p>
-        </p:txBody>
-      </p:sp>
-      <p:sp>
-        <p:nvSpPr>
-          <p:cNvPr id="35" name="Text 33"/>
-          <p:cNvSpPr/>
-          <p:nvPr/>
-        </p:nvSpPr>
-        <p:spPr>
-          <a:xfrm>
-            <a:off x="3493008" y="3337560"/>
-            <a:ext cx="182880" cy="320040"/>
-          </a:xfrm>
-          <a:prstGeom prst="rect">
-            <a:avLst/>
-          </a:prstGeom>
-          <a:noFill/>
-          <a:ln/>
-        </p:spPr>
-        <p:txBody>
-          <a:bodyPr wrap="square" rtlCol="0" anchor="ctr"/>
-          <a:lstStyle/>
-          <a:p>
-            <a:pPr marL="0" indent="0" algn="ctr">
-              <a:buNone/>
-            </a:pPr>
-            <a:r>
-              <a:rPr lang="en-US" sz="1200" dirty="0">
-                <a:solidFill>
-                  <a:srgbClr val="8BAFC4"/>
-                </a:solidFill>
-              </a:rPr>
-              <a:t>→</a:t>
-            </a:r>
-            <a:endParaRPr lang="en-US" sz="1200" dirty="0"/>
-          </a:p>
-        </p:txBody>
-      </p:sp>
-      <p:sp>
-        <p:nvSpPr>
-          <p:cNvPr id="36" name="Shape 34"/>
-          <p:cNvSpPr/>
-          <p:nvPr/>
-        </p:nvSpPr>
-        <p:spPr>
-          <a:xfrm>
-            <a:off x="3675888" y="3246120"/>
-            <a:ext cx="1600200" cy="502920"/>
-          </a:xfrm>
-          <a:prstGeom prst="rect">
-            <a:avLst/>
-          </a:prstGeom>
-          <a:solidFill>
-            <a:srgbClr val="0E2A45"/>
-          </a:solidFill>
-          <a:ln w="12700">
-            <a:solidFill>
-              <a:srgbClr val="1DB8C9"/>
-            </a:solidFill>
-            <a:prstDash val="solid"/>
-          </a:ln>
-        </p:spPr>
-      </p:sp>
-      <p:sp>
-        <p:nvSpPr>
-          <p:cNvPr id="37" name="Text 35"/>
-          <p:cNvSpPr/>
-          <p:nvPr/>
-        </p:nvSpPr>
-        <p:spPr>
-          <a:xfrm>
-            <a:off x="3675888" y="3246120"/>
-            <a:ext cx="1600200" cy="502920"/>
-          </a:xfrm>
-          <a:prstGeom prst="rect">
-            <a:avLst/>
-          </a:prstGeom>
-          <a:noFill/>
-          <a:ln/>
-        </p:spPr>
-        <p:txBody>
-          <a:bodyPr wrap="square" rtlCol="0" anchor="ctr"/>
-          <a:lstStyle/>
-          <a:p>
-            <a:pPr marL="0" indent="0" algn="ctr">
-              <a:buNone/>
-            </a:pPr>
-            <a:r>
-              <a:rPr lang="en-US" sz="1000" dirty="0">
-                <a:solidFill>
-                  <a:srgbClr val="FFFFFF"/>
-                </a:solidFill>
-                <a:latin typeface="Calibri" pitchFamily="34" charset="0"/>
-                <a:ea typeface="Calibri" pitchFamily="34" charset="-122"/>
-                <a:cs typeface="Calibri" pitchFamily="34" charset="-120"/>
-              </a:rPr>
-              <a:t>Text Chunker</a:t>
-            </a:r>
-            <a:endParaRPr lang="en-US" sz="1000" dirty="0"/>
-          </a:p>
-        </p:txBody>
-      </p:sp>
-      <p:sp>
-        <p:nvSpPr>
-          <p:cNvPr id="38" name="Text 36"/>
-          <p:cNvSpPr/>
-          <p:nvPr/>
-        </p:nvSpPr>
-        <p:spPr>
-          <a:xfrm>
-            <a:off x="5276088" y="3337560"/>
-            <a:ext cx="182880" cy="320040"/>
-          </a:xfrm>
-          <a:prstGeom prst="rect">
-            <a:avLst/>
-          </a:prstGeom>
-          <a:noFill/>
-          <a:ln/>
-        </p:spPr>
-        <p:txBody>
-          <a:bodyPr wrap="square" rtlCol="0" anchor="ctr"/>
-          <a:lstStyle/>
-          <a:p>
-            <a:pPr marL="0" indent="0" algn="ctr">
-              <a:buNone/>
-            </a:pPr>
-            <a:r>
-              <a:rPr lang="en-US" sz="1200" dirty="0">
-                <a:solidFill>
-                  <a:srgbClr val="8BAFC4"/>
-                </a:solidFill>
-              </a:rPr>
-              <a:t>→</a:t>
-            </a:r>
-            <a:endParaRPr lang="en-US" sz="1200" dirty="0"/>
-          </a:p>
-        </p:txBody>
-      </p:sp>
-      <p:sp>
-        <p:nvSpPr>
-          <p:cNvPr id="39" name="Shape 37"/>
-          <p:cNvSpPr/>
-          <p:nvPr/>
-        </p:nvSpPr>
-        <p:spPr>
-          <a:xfrm>
-            <a:off x="5458968" y="3246120"/>
-            <a:ext cx="1600200" cy="502920"/>
-          </a:xfrm>
-          <a:prstGeom prst="rect">
-            <a:avLst/>
-          </a:prstGeom>
-          <a:solidFill>
-            <a:srgbClr val="0E2A45"/>
-          </a:solidFill>
-          <a:ln w="12700">
-            <a:solidFill>
-              <a:srgbClr val="1DB8C9"/>
-            </a:solidFill>
-            <a:prstDash val="solid"/>
-          </a:ln>
-        </p:spPr>
-      </p:sp>
-      <p:sp>
-        <p:nvSpPr>
-          <p:cNvPr id="40" name="Text 38"/>
-          <p:cNvSpPr/>
-          <p:nvPr/>
-        </p:nvSpPr>
-        <p:spPr>
-          <a:xfrm>
-            <a:off x="5458968" y="3246120"/>
-            <a:ext cx="1600200" cy="502920"/>
-          </a:xfrm>
-          <a:prstGeom prst="rect">
-            <a:avLst/>
-          </a:prstGeom>
-          <a:noFill/>
-          <a:ln/>
-        </p:spPr>
-        <p:txBody>
-          <a:bodyPr wrap="square" rtlCol="0" anchor="ctr"/>
-          <a:lstStyle/>
-          <a:p>
-            <a:pPr marL="0" indent="0" algn="ctr">
-              <a:buNone/>
-            </a:pPr>
-            <a:r>
-              <a:rPr lang="en-US" sz="1000" dirty="0">
-                <a:solidFill>
-                  <a:srgbClr val="FFFFFF"/>
-                </a:solidFill>
-                <a:latin typeface="Calibri" pitchFamily="34" charset="0"/>
-                <a:ea typeface="Calibri" pitchFamily="34" charset="-122"/>
-                <a:cs typeface="Calibri" pitchFamily="34" charset="-120"/>
-              </a:rPr>
-              <a:t>MiniLM Encoder</a:t>
-            </a:r>
-            <a:endParaRPr lang="en-US" sz="1000" dirty="0"/>
-          </a:p>
-        </p:txBody>
-      </p:sp>
-      <p:sp>
-        <p:nvSpPr>
-          <p:cNvPr id="41" name="Text 39"/>
-          <p:cNvSpPr/>
-          <p:nvPr/>
-        </p:nvSpPr>
-        <p:spPr>
-          <a:xfrm>
-            <a:off x="7059168" y="3337560"/>
-            <a:ext cx="182880" cy="320040"/>
-          </a:xfrm>
-          <a:prstGeom prst="rect">
-            <a:avLst/>
-          </a:prstGeom>
-          <a:noFill/>
-          <a:ln/>
-        </p:spPr>
-        <p:txBody>
-          <a:bodyPr wrap="square" rtlCol="0" anchor="ctr"/>
-          <a:lstStyle/>
-          <a:p>
-            <a:pPr marL="0" indent="0" algn="ctr">
-              <a:buNone/>
-            </a:pPr>
-            <a:r>
-              <a:rPr lang="en-US" sz="1200" dirty="0">
-                <a:solidFill>
-                  <a:srgbClr val="8BAFC4"/>
-                </a:solidFill>
-              </a:rPr>
-              <a:t>→</a:t>
-            </a:r>
-            <a:endParaRPr lang="en-US" sz="1200" dirty="0"/>
-          </a:p>
-        </p:txBody>
-      </p:sp>
-      <p:sp>
-        <p:nvSpPr>
-          <p:cNvPr id="42" name="Shape 40"/>
-          <p:cNvSpPr/>
-          <p:nvPr/>
-        </p:nvSpPr>
-        <p:spPr>
-          <a:xfrm>
-            <a:off x="7242048" y="3246120"/>
-            <a:ext cx="1600200" cy="502920"/>
-          </a:xfrm>
-          <a:prstGeom prst="rect">
-            <a:avLst/>
-          </a:prstGeom>
-          <a:solidFill>
-            <a:srgbClr val="0D2137"/>
-          </a:solidFill>
-          <a:ln w="12700">
-            <a:solidFill>
-              <a:srgbClr val="1DB8C9"/>
-            </a:solidFill>
-            <a:prstDash val="solid"/>
-          </a:ln>
-        </p:spPr>
-      </p:sp>
-      <p:sp>
-        <p:nvSpPr>
-          <p:cNvPr id="43" name="Text 41"/>
-          <p:cNvSpPr/>
-          <p:nvPr/>
-        </p:nvSpPr>
-        <p:spPr>
-          <a:xfrm>
-            <a:off x="7242048" y="3246120"/>
-            <a:ext cx="1600200" cy="502920"/>
-          </a:xfrm>
-          <a:prstGeom prst="rect">
-            <a:avLst/>
-          </a:prstGeom>
-          <a:noFill/>
-          <a:ln/>
-        </p:spPr>
-        <p:txBody>
-          <a:bodyPr wrap="square" rtlCol="0" anchor="ctr"/>
-          <a:lstStyle/>
-          <a:p>
-            <a:pPr marL="0" indent="0" algn="ctr">
-              <a:buNone/>
-            </a:pPr>
-            <a:r>
-              <a:rPr lang="en-US" sz="1000" b="1" dirty="0">
-                <a:solidFill>
-                  <a:srgbClr val="FFFFFF"/>
-                </a:solidFill>
-                <a:latin typeface="Calibri" pitchFamily="34" charset="0"/>
-                <a:ea typeface="Calibri" pitchFamily="34" charset="-122"/>
-                <a:cs typeface="Calibri" pitchFamily="34" charset="-120"/>
-              </a:rPr>
-              <a:t>FAISS Index + Pickle</a:t>
-            </a:r>
-            <a:endParaRPr lang="en-US" sz="1000" dirty="0"/>
-          </a:p>
-        </p:txBody>
-      </p:sp>
-      <p:sp>
-        <p:nvSpPr>
-          <p:cNvPr id="44" name="Text 42"/>
-          <p:cNvSpPr/>
-          <p:nvPr/>
-        </p:nvSpPr>
-        <p:spPr>
-          <a:xfrm>
-            <a:off x="365760" y="3931920"/>
-            <a:ext cx="1371600" cy="274320"/>
-          </a:xfrm>
-          <a:prstGeom prst="rect">
-            <a:avLst/>
-          </a:prstGeom>
-          <a:noFill/>
-          <a:ln/>
-        </p:spPr>
-        <p:txBody>
-          <a:bodyPr wrap="square" rtlCol="0" anchor="ctr"/>
-          <a:lstStyle/>
-          <a:p>
-            <a:pPr marL="0" indent="0">
-              <a:buNone/>
-            </a:pPr>
-            <a:r>
-              <a:rPr lang="en-US" sz="1000" b="1" dirty="0">
-                <a:solidFill>
-                  <a:srgbClr val="00C8FF"/>
-                </a:solidFill>
-                <a:latin typeface="Calibri" pitchFamily="34" charset="0"/>
-                <a:ea typeface="Calibri" pitchFamily="34" charset="-122"/>
-                <a:cs typeface="Calibri" pitchFamily="34" charset="-120"/>
-              </a:rPr>
-              <a:t>Tech Stack:</a:t>
-            </a:r>
-            <a:endParaRPr lang="en-US" sz="1000" dirty="0"/>
-          </a:p>
-        </p:txBody>
-      </p:sp>
-      <p:sp>
-        <p:nvSpPr>
-          <p:cNvPr id="45" name="Text 43"/>
-          <p:cNvSpPr/>
-          <p:nvPr/>
-        </p:nvSpPr>
-        <p:spPr>
-          <a:xfrm>
-            <a:off x="365760" y="4224528"/>
-            <a:ext cx="8412480" cy="274320"/>
-          </a:xfrm>
-          <a:prstGeom prst="rect">
-            <a:avLst/>
-          </a:prstGeom>
-          <a:noFill/>
-          <a:ln/>
-        </p:spPr>
-        <p:txBody>
-          <a:bodyPr wrap="square" rtlCol="0" anchor="ctr"/>
-          <a:lstStyle/>
-          <a:p>
-            <a:pPr marL="0" indent="0">
-              <a:buNone/>
-            </a:pPr>
-            <a:r>
-              <a:rPr lang="en-US" sz="1000" dirty="0">
-                <a:solidFill>
-                  <a:srgbClr val="FFFFFF"/>
-                </a:solidFill>
-                <a:latin typeface="Calibri" pitchFamily="34" charset="0"/>
-                <a:ea typeface="Calibri" pitchFamily="34" charset="-122"/>
-                <a:cs typeface="Calibri" pitchFamily="34" charset="-120"/>
-              </a:rPr>
-              <a:t>SentenceTransformers  •  FAISS-CPU  •  Groq API (Llama 3.1 8B)  •  PyMuPDF  •  Streamlit  •  Python 3.9+</a:t>
-            </a:r>
-            <a:endParaRPr lang="en-US" sz="1000" dirty="0"/>
-          </a:p>
-        </p:txBody>
-      </p:sp>
+      <p:pic>
+        <p:nvPicPr>
+          <p:cNvPr id="3" name="Picture 2">
+            <a:extLst>
+              <a:ext uri="{FF2B5EF4-FFF2-40B4-BE49-F238E27FC236}">
+                <a16:creationId xmlns:a16="http://schemas.microsoft.com/office/drawing/2014/main" id="{61A1CA85-4B32-BC1E-755E-6433C03D512C}"/>
+              </a:ext>
+            </a:extLst>
+          </p:cNvPr>
+          <p:cNvPicPr>
+            <a:picLocks noChangeAspect="1"/>
+          </p:cNvPicPr>
+          <p:nvPr/>
+        </p:nvPicPr>
+        <p:blipFill>
+          <a:blip r:embed="rId2"/>
+          <a:stretch>
+            <a:fillRect/>
+          </a:stretch>
+        </p:blipFill>
+        <p:spPr>
+          <a:xfrm>
+            <a:off x="0" y="-1"/>
+            <a:ext cx="9144000" cy="5143501"/>
+          </a:xfrm>
+          <a:prstGeom prst="rect">
+            <a:avLst/>
+          </a:prstGeom>
+        </p:spPr>
+      </p:pic>
     </p:spTree>
+    <p:extLst>
+      <p:ext uri="{BB962C8B-B14F-4D97-AF65-F5344CB8AC3E}">
+        <p14:creationId xmlns:p14="http://schemas.microsoft.com/office/powerpoint/2010/main" val="4118586888"/>
+      </p:ext>
+    </p:extLst>
   </p:cSld>
   <p:clrMapOvr>
     <a:masterClrMapping/>

</xml_diff>